<commit_message>
rebuild seminar deck from notes, add latex table renderer
</commit_message>
<xml_diff>
--- a/Seminar/deck.pptx
+++ b/Seminar/deck.pptx
@@ -17,6 +17,27 @@
     <p:sldId id="265" r:id="rId11"/>
     <p:sldId id="266" r:id="rId12"/>
     <p:sldId id="267" r:id="rId13"/>
+    <p:sldId id="268" r:id="rId14"/>
+    <p:sldId id="269" r:id="rId15"/>
+    <p:sldId id="270" r:id="rId16"/>
+    <p:sldId id="271" r:id="rId17"/>
+    <p:sldId id="272" r:id="rId18"/>
+    <p:sldId id="273" r:id="rId19"/>
+    <p:sldId id="274" r:id="rId20"/>
+    <p:sldId id="275" r:id="rId21"/>
+    <p:sldId id="276" r:id="rId22"/>
+    <p:sldId id="277" r:id="rId23"/>
+    <p:sldId id="278" r:id="rId24"/>
+    <p:sldId id="279" r:id="rId25"/>
+    <p:sldId id="280" r:id="rId26"/>
+    <p:sldId id="281" r:id="rId27"/>
+    <p:sldId id="282" r:id="rId28"/>
+    <p:sldId id="283" r:id="rId29"/>
+    <p:sldId id="284" r:id="rId30"/>
+    <p:sldId id="285" r:id="rId31"/>
+    <p:sldId id="286" r:id="rId32"/>
+    <p:sldId id="287" r:id="rId33"/>
+    <p:sldId id="288" r:id="rId34"/>
   </p:sldIdLst>
   <p:sldSz cx="12192000" cy="6858000"/>
   <p:notesSz cx="6858000" cy="9144000"/>
@@ -270,6 +291,349 @@
 </p:sld>
 </file>
 
+<file path=ppt/slides/slide13.xml><?xml version="1.0" encoding="utf-8"?>
+<p:sld xmlns:a="http://schemas.openxmlformats.org/drawingml/2006/main" xmlns:r="http://schemas.openxmlformats.org/officeDocument/2006/relationships" xmlns:p="http://schemas.openxmlformats.org/presentationml/2006/main">
+  <p:cSld>
+    <p:spTree>
+      <p:nvGrpSpPr>
+        <p:cNvPr id="1" name=""/>
+        <p:cNvGrpSpPr/>
+        <p:nvPr/>
+      </p:nvGrpSpPr>
+      <p:grpSpPr>
+        <a:xfrm>
+          <a:off x="0" y="0"/>
+          <a:ext cx="0" cy="0"/>
+          <a:chOff x="0" y="0"/>
+          <a:chExt cx="0" cy="0"/>
+        </a:xfrm>
+      </p:grpSpPr>
+      <p:pic>
+        <p:nvPicPr>
+          <p:cNvPr id="2" name="Slide 13"/>
+          <p:cNvPicPr>
+            <a:picLocks noChangeAspect="1"/>
+          </p:cNvPicPr>
+          <p:nvPr/>
+        </p:nvPicPr>
+        <p:blipFill>
+          <a:blip r:embed="rId2"/>
+          <a:stretch>
+            <a:fillRect/>
+          </a:stretch>
+        </p:blipFill>
+        <p:spPr>
+          <a:xfrm>
+            <a:off x="0" y="0"/>
+            <a:ext cx="12192000" cy="6858000"/>
+          </a:xfrm>
+          <a:prstGeom prst="rect">
+            <a:avLst/>
+          </a:prstGeom>
+        </p:spPr>
+      </p:pic>
+    </p:spTree>
+  </p:cSld>
+  <p:clrMapOvr>
+    <a:masterClrMapping/>
+  </p:clrMapOvr>
+</p:sld>
+</file>
+
+<file path=ppt/slides/slide14.xml><?xml version="1.0" encoding="utf-8"?>
+<p:sld xmlns:a="http://schemas.openxmlformats.org/drawingml/2006/main" xmlns:r="http://schemas.openxmlformats.org/officeDocument/2006/relationships" xmlns:p="http://schemas.openxmlformats.org/presentationml/2006/main">
+  <p:cSld>
+    <p:spTree>
+      <p:nvGrpSpPr>
+        <p:cNvPr id="1" name=""/>
+        <p:cNvGrpSpPr/>
+        <p:nvPr/>
+      </p:nvGrpSpPr>
+      <p:grpSpPr>
+        <a:xfrm>
+          <a:off x="0" y="0"/>
+          <a:ext cx="0" cy="0"/>
+          <a:chOff x="0" y="0"/>
+          <a:chExt cx="0" cy="0"/>
+        </a:xfrm>
+      </p:grpSpPr>
+      <p:pic>
+        <p:nvPicPr>
+          <p:cNvPr id="2" name="Slide 14"/>
+          <p:cNvPicPr>
+            <a:picLocks noChangeAspect="1"/>
+          </p:cNvPicPr>
+          <p:nvPr/>
+        </p:nvPicPr>
+        <p:blipFill>
+          <a:blip r:embed="rId2"/>
+          <a:stretch>
+            <a:fillRect/>
+          </a:stretch>
+        </p:blipFill>
+        <p:spPr>
+          <a:xfrm>
+            <a:off x="0" y="0"/>
+            <a:ext cx="12192000" cy="6858000"/>
+          </a:xfrm>
+          <a:prstGeom prst="rect">
+            <a:avLst/>
+          </a:prstGeom>
+        </p:spPr>
+      </p:pic>
+    </p:spTree>
+  </p:cSld>
+  <p:clrMapOvr>
+    <a:masterClrMapping/>
+  </p:clrMapOvr>
+</p:sld>
+</file>
+
+<file path=ppt/slides/slide15.xml><?xml version="1.0" encoding="utf-8"?>
+<p:sld xmlns:a="http://schemas.openxmlformats.org/drawingml/2006/main" xmlns:r="http://schemas.openxmlformats.org/officeDocument/2006/relationships" xmlns:p="http://schemas.openxmlformats.org/presentationml/2006/main">
+  <p:cSld>
+    <p:spTree>
+      <p:nvGrpSpPr>
+        <p:cNvPr id="1" name=""/>
+        <p:cNvGrpSpPr/>
+        <p:nvPr/>
+      </p:nvGrpSpPr>
+      <p:grpSpPr>
+        <a:xfrm>
+          <a:off x="0" y="0"/>
+          <a:ext cx="0" cy="0"/>
+          <a:chOff x="0" y="0"/>
+          <a:chExt cx="0" cy="0"/>
+        </a:xfrm>
+      </p:grpSpPr>
+      <p:pic>
+        <p:nvPicPr>
+          <p:cNvPr id="2" name="Slide 15"/>
+          <p:cNvPicPr>
+            <a:picLocks noChangeAspect="1"/>
+          </p:cNvPicPr>
+          <p:nvPr/>
+        </p:nvPicPr>
+        <p:blipFill>
+          <a:blip r:embed="rId2"/>
+          <a:stretch>
+            <a:fillRect/>
+          </a:stretch>
+        </p:blipFill>
+        <p:spPr>
+          <a:xfrm>
+            <a:off x="0" y="0"/>
+            <a:ext cx="12192000" cy="6858000"/>
+          </a:xfrm>
+          <a:prstGeom prst="rect">
+            <a:avLst/>
+          </a:prstGeom>
+        </p:spPr>
+      </p:pic>
+    </p:spTree>
+  </p:cSld>
+  <p:clrMapOvr>
+    <a:masterClrMapping/>
+  </p:clrMapOvr>
+</p:sld>
+</file>
+
+<file path=ppt/slides/slide16.xml><?xml version="1.0" encoding="utf-8"?>
+<p:sld xmlns:a="http://schemas.openxmlformats.org/drawingml/2006/main" xmlns:r="http://schemas.openxmlformats.org/officeDocument/2006/relationships" xmlns:p="http://schemas.openxmlformats.org/presentationml/2006/main">
+  <p:cSld>
+    <p:spTree>
+      <p:nvGrpSpPr>
+        <p:cNvPr id="1" name=""/>
+        <p:cNvGrpSpPr/>
+        <p:nvPr/>
+      </p:nvGrpSpPr>
+      <p:grpSpPr>
+        <a:xfrm>
+          <a:off x="0" y="0"/>
+          <a:ext cx="0" cy="0"/>
+          <a:chOff x="0" y="0"/>
+          <a:chExt cx="0" cy="0"/>
+        </a:xfrm>
+      </p:grpSpPr>
+      <p:pic>
+        <p:nvPicPr>
+          <p:cNvPr id="2" name="Slide 16"/>
+          <p:cNvPicPr>
+            <a:picLocks noChangeAspect="1"/>
+          </p:cNvPicPr>
+          <p:nvPr/>
+        </p:nvPicPr>
+        <p:blipFill>
+          <a:blip r:embed="rId2"/>
+          <a:stretch>
+            <a:fillRect/>
+          </a:stretch>
+        </p:blipFill>
+        <p:spPr>
+          <a:xfrm>
+            <a:off x="0" y="0"/>
+            <a:ext cx="12192000" cy="6858000"/>
+          </a:xfrm>
+          <a:prstGeom prst="rect">
+            <a:avLst/>
+          </a:prstGeom>
+        </p:spPr>
+      </p:pic>
+    </p:spTree>
+  </p:cSld>
+  <p:clrMapOvr>
+    <a:masterClrMapping/>
+  </p:clrMapOvr>
+</p:sld>
+</file>
+
+<file path=ppt/slides/slide17.xml><?xml version="1.0" encoding="utf-8"?>
+<p:sld xmlns:a="http://schemas.openxmlformats.org/drawingml/2006/main" xmlns:r="http://schemas.openxmlformats.org/officeDocument/2006/relationships" xmlns:p="http://schemas.openxmlformats.org/presentationml/2006/main">
+  <p:cSld>
+    <p:spTree>
+      <p:nvGrpSpPr>
+        <p:cNvPr id="1" name=""/>
+        <p:cNvGrpSpPr/>
+        <p:nvPr/>
+      </p:nvGrpSpPr>
+      <p:grpSpPr>
+        <a:xfrm>
+          <a:off x="0" y="0"/>
+          <a:ext cx="0" cy="0"/>
+          <a:chOff x="0" y="0"/>
+          <a:chExt cx="0" cy="0"/>
+        </a:xfrm>
+      </p:grpSpPr>
+      <p:pic>
+        <p:nvPicPr>
+          <p:cNvPr id="2" name="Slide 17"/>
+          <p:cNvPicPr>
+            <a:picLocks noChangeAspect="1"/>
+          </p:cNvPicPr>
+          <p:nvPr/>
+        </p:nvPicPr>
+        <p:blipFill>
+          <a:blip r:embed="rId2"/>
+          <a:stretch>
+            <a:fillRect/>
+          </a:stretch>
+        </p:blipFill>
+        <p:spPr>
+          <a:xfrm>
+            <a:off x="0" y="0"/>
+            <a:ext cx="12192000" cy="6858000"/>
+          </a:xfrm>
+          <a:prstGeom prst="rect">
+            <a:avLst/>
+          </a:prstGeom>
+        </p:spPr>
+      </p:pic>
+    </p:spTree>
+  </p:cSld>
+  <p:clrMapOvr>
+    <a:masterClrMapping/>
+  </p:clrMapOvr>
+</p:sld>
+</file>
+
+<file path=ppt/slides/slide18.xml><?xml version="1.0" encoding="utf-8"?>
+<p:sld xmlns:a="http://schemas.openxmlformats.org/drawingml/2006/main" xmlns:r="http://schemas.openxmlformats.org/officeDocument/2006/relationships" xmlns:p="http://schemas.openxmlformats.org/presentationml/2006/main">
+  <p:cSld>
+    <p:spTree>
+      <p:nvGrpSpPr>
+        <p:cNvPr id="1" name=""/>
+        <p:cNvGrpSpPr/>
+        <p:nvPr/>
+      </p:nvGrpSpPr>
+      <p:grpSpPr>
+        <a:xfrm>
+          <a:off x="0" y="0"/>
+          <a:ext cx="0" cy="0"/>
+          <a:chOff x="0" y="0"/>
+          <a:chExt cx="0" cy="0"/>
+        </a:xfrm>
+      </p:grpSpPr>
+      <p:pic>
+        <p:nvPicPr>
+          <p:cNvPr id="2" name="Slide 18"/>
+          <p:cNvPicPr>
+            <a:picLocks noChangeAspect="1"/>
+          </p:cNvPicPr>
+          <p:nvPr/>
+        </p:nvPicPr>
+        <p:blipFill>
+          <a:blip r:embed="rId2"/>
+          <a:stretch>
+            <a:fillRect/>
+          </a:stretch>
+        </p:blipFill>
+        <p:spPr>
+          <a:xfrm>
+            <a:off x="0" y="0"/>
+            <a:ext cx="12192000" cy="6858000"/>
+          </a:xfrm>
+          <a:prstGeom prst="rect">
+            <a:avLst/>
+          </a:prstGeom>
+        </p:spPr>
+      </p:pic>
+    </p:spTree>
+  </p:cSld>
+  <p:clrMapOvr>
+    <a:masterClrMapping/>
+  </p:clrMapOvr>
+</p:sld>
+</file>
+
+<file path=ppt/slides/slide19.xml><?xml version="1.0" encoding="utf-8"?>
+<p:sld xmlns:a="http://schemas.openxmlformats.org/drawingml/2006/main" xmlns:r="http://schemas.openxmlformats.org/officeDocument/2006/relationships" xmlns:p="http://schemas.openxmlformats.org/presentationml/2006/main">
+  <p:cSld>
+    <p:spTree>
+      <p:nvGrpSpPr>
+        <p:cNvPr id="1" name=""/>
+        <p:cNvGrpSpPr/>
+        <p:nvPr/>
+      </p:nvGrpSpPr>
+      <p:grpSpPr>
+        <a:xfrm>
+          <a:off x="0" y="0"/>
+          <a:ext cx="0" cy="0"/>
+          <a:chOff x="0" y="0"/>
+          <a:chExt cx="0" cy="0"/>
+        </a:xfrm>
+      </p:grpSpPr>
+      <p:pic>
+        <p:nvPicPr>
+          <p:cNvPr id="2" name="Slide 19"/>
+          <p:cNvPicPr>
+            <a:picLocks noChangeAspect="1"/>
+          </p:cNvPicPr>
+          <p:nvPr/>
+        </p:nvPicPr>
+        <p:blipFill>
+          <a:blip r:embed="rId2"/>
+          <a:stretch>
+            <a:fillRect/>
+          </a:stretch>
+        </p:blipFill>
+        <p:spPr>
+          <a:xfrm>
+            <a:off x="0" y="0"/>
+            <a:ext cx="12192000" cy="6858000"/>
+          </a:xfrm>
+          <a:prstGeom prst="rect">
+            <a:avLst/>
+          </a:prstGeom>
+        </p:spPr>
+      </p:pic>
+    </p:spTree>
+  </p:cSld>
+  <p:clrMapOvr>
+    <a:masterClrMapping/>
+  </p:clrMapOvr>
+</p:sld>
+</file>
+
 <file path=ppt/slides/slide2.xml><?xml version="1.0" encoding="utf-8"?>
 <p:sld xmlns:a="http://schemas.openxmlformats.org/drawingml/2006/main" xmlns:r="http://schemas.openxmlformats.org/officeDocument/2006/relationships" xmlns:p="http://schemas.openxmlformats.org/presentationml/2006/main">
   <p:cSld>
@@ -319,6 +683,496 @@
 </p:sld>
 </file>
 
+<file path=ppt/slides/slide20.xml><?xml version="1.0" encoding="utf-8"?>
+<p:sld xmlns:a="http://schemas.openxmlformats.org/drawingml/2006/main" xmlns:r="http://schemas.openxmlformats.org/officeDocument/2006/relationships" xmlns:p="http://schemas.openxmlformats.org/presentationml/2006/main">
+  <p:cSld>
+    <p:spTree>
+      <p:nvGrpSpPr>
+        <p:cNvPr id="1" name=""/>
+        <p:cNvGrpSpPr/>
+        <p:nvPr/>
+      </p:nvGrpSpPr>
+      <p:grpSpPr>
+        <a:xfrm>
+          <a:off x="0" y="0"/>
+          <a:ext cx="0" cy="0"/>
+          <a:chOff x="0" y="0"/>
+          <a:chExt cx="0" cy="0"/>
+        </a:xfrm>
+      </p:grpSpPr>
+      <p:pic>
+        <p:nvPicPr>
+          <p:cNvPr id="2" name="Slide 20"/>
+          <p:cNvPicPr>
+            <a:picLocks noChangeAspect="1"/>
+          </p:cNvPicPr>
+          <p:nvPr/>
+        </p:nvPicPr>
+        <p:blipFill>
+          <a:blip r:embed="rId2"/>
+          <a:stretch>
+            <a:fillRect/>
+          </a:stretch>
+        </p:blipFill>
+        <p:spPr>
+          <a:xfrm>
+            <a:off x="0" y="0"/>
+            <a:ext cx="12192000" cy="6858000"/>
+          </a:xfrm>
+          <a:prstGeom prst="rect">
+            <a:avLst/>
+          </a:prstGeom>
+        </p:spPr>
+      </p:pic>
+    </p:spTree>
+  </p:cSld>
+  <p:clrMapOvr>
+    <a:masterClrMapping/>
+  </p:clrMapOvr>
+</p:sld>
+</file>
+
+<file path=ppt/slides/slide21.xml><?xml version="1.0" encoding="utf-8"?>
+<p:sld xmlns:a="http://schemas.openxmlformats.org/drawingml/2006/main" xmlns:r="http://schemas.openxmlformats.org/officeDocument/2006/relationships" xmlns:p="http://schemas.openxmlformats.org/presentationml/2006/main">
+  <p:cSld>
+    <p:spTree>
+      <p:nvGrpSpPr>
+        <p:cNvPr id="1" name=""/>
+        <p:cNvGrpSpPr/>
+        <p:nvPr/>
+      </p:nvGrpSpPr>
+      <p:grpSpPr>
+        <a:xfrm>
+          <a:off x="0" y="0"/>
+          <a:ext cx="0" cy="0"/>
+          <a:chOff x="0" y="0"/>
+          <a:chExt cx="0" cy="0"/>
+        </a:xfrm>
+      </p:grpSpPr>
+      <p:pic>
+        <p:nvPicPr>
+          <p:cNvPr id="2" name="Slide 21"/>
+          <p:cNvPicPr>
+            <a:picLocks noChangeAspect="1"/>
+          </p:cNvPicPr>
+          <p:nvPr/>
+        </p:nvPicPr>
+        <p:blipFill>
+          <a:blip r:embed="rId2"/>
+          <a:stretch>
+            <a:fillRect/>
+          </a:stretch>
+        </p:blipFill>
+        <p:spPr>
+          <a:xfrm>
+            <a:off x="0" y="0"/>
+            <a:ext cx="12192000" cy="6858000"/>
+          </a:xfrm>
+          <a:prstGeom prst="rect">
+            <a:avLst/>
+          </a:prstGeom>
+        </p:spPr>
+      </p:pic>
+    </p:spTree>
+  </p:cSld>
+  <p:clrMapOvr>
+    <a:masterClrMapping/>
+  </p:clrMapOvr>
+</p:sld>
+</file>
+
+<file path=ppt/slides/slide22.xml><?xml version="1.0" encoding="utf-8"?>
+<p:sld xmlns:a="http://schemas.openxmlformats.org/drawingml/2006/main" xmlns:r="http://schemas.openxmlformats.org/officeDocument/2006/relationships" xmlns:p="http://schemas.openxmlformats.org/presentationml/2006/main">
+  <p:cSld>
+    <p:spTree>
+      <p:nvGrpSpPr>
+        <p:cNvPr id="1" name=""/>
+        <p:cNvGrpSpPr/>
+        <p:nvPr/>
+      </p:nvGrpSpPr>
+      <p:grpSpPr>
+        <a:xfrm>
+          <a:off x="0" y="0"/>
+          <a:ext cx="0" cy="0"/>
+          <a:chOff x="0" y="0"/>
+          <a:chExt cx="0" cy="0"/>
+        </a:xfrm>
+      </p:grpSpPr>
+      <p:pic>
+        <p:nvPicPr>
+          <p:cNvPr id="2" name="Slide 22"/>
+          <p:cNvPicPr>
+            <a:picLocks noChangeAspect="1"/>
+          </p:cNvPicPr>
+          <p:nvPr/>
+        </p:nvPicPr>
+        <p:blipFill>
+          <a:blip r:embed="rId2"/>
+          <a:stretch>
+            <a:fillRect/>
+          </a:stretch>
+        </p:blipFill>
+        <p:spPr>
+          <a:xfrm>
+            <a:off x="0" y="0"/>
+            <a:ext cx="12192000" cy="6858000"/>
+          </a:xfrm>
+          <a:prstGeom prst="rect">
+            <a:avLst/>
+          </a:prstGeom>
+        </p:spPr>
+      </p:pic>
+    </p:spTree>
+  </p:cSld>
+  <p:clrMapOvr>
+    <a:masterClrMapping/>
+  </p:clrMapOvr>
+</p:sld>
+</file>
+
+<file path=ppt/slides/slide23.xml><?xml version="1.0" encoding="utf-8"?>
+<p:sld xmlns:a="http://schemas.openxmlformats.org/drawingml/2006/main" xmlns:r="http://schemas.openxmlformats.org/officeDocument/2006/relationships" xmlns:p="http://schemas.openxmlformats.org/presentationml/2006/main">
+  <p:cSld>
+    <p:spTree>
+      <p:nvGrpSpPr>
+        <p:cNvPr id="1" name=""/>
+        <p:cNvGrpSpPr/>
+        <p:nvPr/>
+      </p:nvGrpSpPr>
+      <p:grpSpPr>
+        <a:xfrm>
+          <a:off x="0" y="0"/>
+          <a:ext cx="0" cy="0"/>
+          <a:chOff x="0" y="0"/>
+          <a:chExt cx="0" cy="0"/>
+        </a:xfrm>
+      </p:grpSpPr>
+      <p:pic>
+        <p:nvPicPr>
+          <p:cNvPr id="2" name="Slide 23"/>
+          <p:cNvPicPr>
+            <a:picLocks noChangeAspect="1"/>
+          </p:cNvPicPr>
+          <p:nvPr/>
+        </p:nvPicPr>
+        <p:blipFill>
+          <a:blip r:embed="rId2"/>
+          <a:stretch>
+            <a:fillRect/>
+          </a:stretch>
+        </p:blipFill>
+        <p:spPr>
+          <a:xfrm>
+            <a:off x="0" y="0"/>
+            <a:ext cx="12192000" cy="6858000"/>
+          </a:xfrm>
+          <a:prstGeom prst="rect">
+            <a:avLst/>
+          </a:prstGeom>
+        </p:spPr>
+      </p:pic>
+    </p:spTree>
+  </p:cSld>
+  <p:clrMapOvr>
+    <a:masterClrMapping/>
+  </p:clrMapOvr>
+</p:sld>
+</file>
+
+<file path=ppt/slides/slide24.xml><?xml version="1.0" encoding="utf-8"?>
+<p:sld xmlns:a="http://schemas.openxmlformats.org/drawingml/2006/main" xmlns:r="http://schemas.openxmlformats.org/officeDocument/2006/relationships" xmlns:p="http://schemas.openxmlformats.org/presentationml/2006/main">
+  <p:cSld>
+    <p:spTree>
+      <p:nvGrpSpPr>
+        <p:cNvPr id="1" name=""/>
+        <p:cNvGrpSpPr/>
+        <p:nvPr/>
+      </p:nvGrpSpPr>
+      <p:grpSpPr>
+        <a:xfrm>
+          <a:off x="0" y="0"/>
+          <a:ext cx="0" cy="0"/>
+          <a:chOff x="0" y="0"/>
+          <a:chExt cx="0" cy="0"/>
+        </a:xfrm>
+      </p:grpSpPr>
+      <p:pic>
+        <p:nvPicPr>
+          <p:cNvPr id="2" name="Slide 24"/>
+          <p:cNvPicPr>
+            <a:picLocks noChangeAspect="1"/>
+          </p:cNvPicPr>
+          <p:nvPr/>
+        </p:nvPicPr>
+        <p:blipFill>
+          <a:blip r:embed="rId2"/>
+          <a:stretch>
+            <a:fillRect/>
+          </a:stretch>
+        </p:blipFill>
+        <p:spPr>
+          <a:xfrm>
+            <a:off x="0" y="0"/>
+            <a:ext cx="12192000" cy="6858000"/>
+          </a:xfrm>
+          <a:prstGeom prst="rect">
+            <a:avLst/>
+          </a:prstGeom>
+        </p:spPr>
+      </p:pic>
+    </p:spTree>
+  </p:cSld>
+  <p:clrMapOvr>
+    <a:masterClrMapping/>
+  </p:clrMapOvr>
+</p:sld>
+</file>
+
+<file path=ppt/slides/slide25.xml><?xml version="1.0" encoding="utf-8"?>
+<p:sld xmlns:a="http://schemas.openxmlformats.org/drawingml/2006/main" xmlns:r="http://schemas.openxmlformats.org/officeDocument/2006/relationships" xmlns:p="http://schemas.openxmlformats.org/presentationml/2006/main">
+  <p:cSld>
+    <p:spTree>
+      <p:nvGrpSpPr>
+        <p:cNvPr id="1" name=""/>
+        <p:cNvGrpSpPr/>
+        <p:nvPr/>
+      </p:nvGrpSpPr>
+      <p:grpSpPr>
+        <a:xfrm>
+          <a:off x="0" y="0"/>
+          <a:ext cx="0" cy="0"/>
+          <a:chOff x="0" y="0"/>
+          <a:chExt cx="0" cy="0"/>
+        </a:xfrm>
+      </p:grpSpPr>
+      <p:pic>
+        <p:nvPicPr>
+          <p:cNvPr id="2" name="Slide 25"/>
+          <p:cNvPicPr>
+            <a:picLocks noChangeAspect="1"/>
+          </p:cNvPicPr>
+          <p:nvPr/>
+        </p:nvPicPr>
+        <p:blipFill>
+          <a:blip r:embed="rId2"/>
+          <a:stretch>
+            <a:fillRect/>
+          </a:stretch>
+        </p:blipFill>
+        <p:spPr>
+          <a:xfrm>
+            <a:off x="0" y="0"/>
+            <a:ext cx="12192000" cy="6858000"/>
+          </a:xfrm>
+          <a:prstGeom prst="rect">
+            <a:avLst/>
+          </a:prstGeom>
+        </p:spPr>
+      </p:pic>
+    </p:spTree>
+  </p:cSld>
+  <p:clrMapOvr>
+    <a:masterClrMapping/>
+  </p:clrMapOvr>
+</p:sld>
+</file>
+
+<file path=ppt/slides/slide26.xml><?xml version="1.0" encoding="utf-8"?>
+<p:sld xmlns:a="http://schemas.openxmlformats.org/drawingml/2006/main" xmlns:r="http://schemas.openxmlformats.org/officeDocument/2006/relationships" xmlns:p="http://schemas.openxmlformats.org/presentationml/2006/main">
+  <p:cSld>
+    <p:spTree>
+      <p:nvGrpSpPr>
+        <p:cNvPr id="1" name=""/>
+        <p:cNvGrpSpPr/>
+        <p:nvPr/>
+      </p:nvGrpSpPr>
+      <p:grpSpPr>
+        <a:xfrm>
+          <a:off x="0" y="0"/>
+          <a:ext cx="0" cy="0"/>
+          <a:chOff x="0" y="0"/>
+          <a:chExt cx="0" cy="0"/>
+        </a:xfrm>
+      </p:grpSpPr>
+      <p:pic>
+        <p:nvPicPr>
+          <p:cNvPr id="2" name="Slide 26"/>
+          <p:cNvPicPr>
+            <a:picLocks noChangeAspect="1"/>
+          </p:cNvPicPr>
+          <p:nvPr/>
+        </p:nvPicPr>
+        <p:blipFill>
+          <a:blip r:embed="rId2"/>
+          <a:stretch>
+            <a:fillRect/>
+          </a:stretch>
+        </p:blipFill>
+        <p:spPr>
+          <a:xfrm>
+            <a:off x="0" y="0"/>
+            <a:ext cx="12192000" cy="6858000"/>
+          </a:xfrm>
+          <a:prstGeom prst="rect">
+            <a:avLst/>
+          </a:prstGeom>
+        </p:spPr>
+      </p:pic>
+    </p:spTree>
+  </p:cSld>
+  <p:clrMapOvr>
+    <a:masterClrMapping/>
+  </p:clrMapOvr>
+</p:sld>
+</file>
+
+<file path=ppt/slides/slide27.xml><?xml version="1.0" encoding="utf-8"?>
+<p:sld xmlns:a="http://schemas.openxmlformats.org/drawingml/2006/main" xmlns:r="http://schemas.openxmlformats.org/officeDocument/2006/relationships" xmlns:p="http://schemas.openxmlformats.org/presentationml/2006/main">
+  <p:cSld>
+    <p:spTree>
+      <p:nvGrpSpPr>
+        <p:cNvPr id="1" name=""/>
+        <p:cNvGrpSpPr/>
+        <p:nvPr/>
+      </p:nvGrpSpPr>
+      <p:grpSpPr>
+        <a:xfrm>
+          <a:off x="0" y="0"/>
+          <a:ext cx="0" cy="0"/>
+          <a:chOff x="0" y="0"/>
+          <a:chExt cx="0" cy="0"/>
+        </a:xfrm>
+      </p:grpSpPr>
+      <p:pic>
+        <p:nvPicPr>
+          <p:cNvPr id="2" name="Slide 27"/>
+          <p:cNvPicPr>
+            <a:picLocks noChangeAspect="1"/>
+          </p:cNvPicPr>
+          <p:nvPr/>
+        </p:nvPicPr>
+        <p:blipFill>
+          <a:blip r:embed="rId2"/>
+          <a:stretch>
+            <a:fillRect/>
+          </a:stretch>
+        </p:blipFill>
+        <p:spPr>
+          <a:xfrm>
+            <a:off x="0" y="0"/>
+            <a:ext cx="12192000" cy="6858000"/>
+          </a:xfrm>
+          <a:prstGeom prst="rect">
+            <a:avLst/>
+          </a:prstGeom>
+        </p:spPr>
+      </p:pic>
+    </p:spTree>
+  </p:cSld>
+  <p:clrMapOvr>
+    <a:masterClrMapping/>
+  </p:clrMapOvr>
+</p:sld>
+</file>
+
+<file path=ppt/slides/slide28.xml><?xml version="1.0" encoding="utf-8"?>
+<p:sld xmlns:a="http://schemas.openxmlformats.org/drawingml/2006/main" xmlns:r="http://schemas.openxmlformats.org/officeDocument/2006/relationships" xmlns:p="http://schemas.openxmlformats.org/presentationml/2006/main">
+  <p:cSld>
+    <p:spTree>
+      <p:nvGrpSpPr>
+        <p:cNvPr id="1" name=""/>
+        <p:cNvGrpSpPr/>
+        <p:nvPr/>
+      </p:nvGrpSpPr>
+      <p:grpSpPr>
+        <a:xfrm>
+          <a:off x="0" y="0"/>
+          <a:ext cx="0" cy="0"/>
+          <a:chOff x="0" y="0"/>
+          <a:chExt cx="0" cy="0"/>
+        </a:xfrm>
+      </p:grpSpPr>
+      <p:pic>
+        <p:nvPicPr>
+          <p:cNvPr id="2" name="Slide 28"/>
+          <p:cNvPicPr>
+            <a:picLocks noChangeAspect="1"/>
+          </p:cNvPicPr>
+          <p:nvPr/>
+        </p:nvPicPr>
+        <p:blipFill>
+          <a:blip r:embed="rId2"/>
+          <a:stretch>
+            <a:fillRect/>
+          </a:stretch>
+        </p:blipFill>
+        <p:spPr>
+          <a:xfrm>
+            <a:off x="0" y="0"/>
+            <a:ext cx="12192000" cy="6858000"/>
+          </a:xfrm>
+          <a:prstGeom prst="rect">
+            <a:avLst/>
+          </a:prstGeom>
+        </p:spPr>
+      </p:pic>
+    </p:spTree>
+  </p:cSld>
+  <p:clrMapOvr>
+    <a:masterClrMapping/>
+  </p:clrMapOvr>
+</p:sld>
+</file>
+
+<file path=ppt/slides/slide29.xml><?xml version="1.0" encoding="utf-8"?>
+<p:sld xmlns:a="http://schemas.openxmlformats.org/drawingml/2006/main" xmlns:r="http://schemas.openxmlformats.org/officeDocument/2006/relationships" xmlns:p="http://schemas.openxmlformats.org/presentationml/2006/main">
+  <p:cSld>
+    <p:spTree>
+      <p:nvGrpSpPr>
+        <p:cNvPr id="1" name=""/>
+        <p:cNvGrpSpPr/>
+        <p:nvPr/>
+      </p:nvGrpSpPr>
+      <p:grpSpPr>
+        <a:xfrm>
+          <a:off x="0" y="0"/>
+          <a:ext cx="0" cy="0"/>
+          <a:chOff x="0" y="0"/>
+          <a:chExt cx="0" cy="0"/>
+        </a:xfrm>
+      </p:grpSpPr>
+      <p:pic>
+        <p:nvPicPr>
+          <p:cNvPr id="2" name="Slide 29"/>
+          <p:cNvPicPr>
+            <a:picLocks noChangeAspect="1"/>
+          </p:cNvPicPr>
+          <p:nvPr/>
+        </p:nvPicPr>
+        <p:blipFill>
+          <a:blip r:embed="rId2"/>
+          <a:stretch>
+            <a:fillRect/>
+          </a:stretch>
+        </p:blipFill>
+        <p:spPr>
+          <a:xfrm>
+            <a:off x="0" y="0"/>
+            <a:ext cx="12192000" cy="6858000"/>
+          </a:xfrm>
+          <a:prstGeom prst="rect">
+            <a:avLst/>
+          </a:prstGeom>
+        </p:spPr>
+      </p:pic>
+    </p:spTree>
+  </p:cSld>
+  <p:clrMapOvr>
+    <a:masterClrMapping/>
+  </p:clrMapOvr>
+</p:sld>
+</file>
+
 <file path=ppt/slides/slide3.xml><?xml version="1.0" encoding="utf-8"?>
 <p:sld xmlns:a="http://schemas.openxmlformats.org/drawingml/2006/main" xmlns:r="http://schemas.openxmlformats.org/officeDocument/2006/relationships" xmlns:p="http://schemas.openxmlformats.org/presentationml/2006/main">
   <p:cSld>
@@ -339,6 +1193,202 @@
       <p:pic>
         <p:nvPicPr>
           <p:cNvPr id="2" name="Slide 3"/>
+          <p:cNvPicPr>
+            <a:picLocks noChangeAspect="1"/>
+          </p:cNvPicPr>
+          <p:nvPr/>
+        </p:nvPicPr>
+        <p:blipFill>
+          <a:blip r:embed="rId2"/>
+          <a:stretch>
+            <a:fillRect/>
+          </a:stretch>
+        </p:blipFill>
+        <p:spPr>
+          <a:xfrm>
+            <a:off x="0" y="0"/>
+            <a:ext cx="12192000" cy="6858000"/>
+          </a:xfrm>
+          <a:prstGeom prst="rect">
+            <a:avLst/>
+          </a:prstGeom>
+        </p:spPr>
+      </p:pic>
+    </p:spTree>
+  </p:cSld>
+  <p:clrMapOvr>
+    <a:masterClrMapping/>
+  </p:clrMapOvr>
+</p:sld>
+</file>
+
+<file path=ppt/slides/slide30.xml><?xml version="1.0" encoding="utf-8"?>
+<p:sld xmlns:a="http://schemas.openxmlformats.org/drawingml/2006/main" xmlns:r="http://schemas.openxmlformats.org/officeDocument/2006/relationships" xmlns:p="http://schemas.openxmlformats.org/presentationml/2006/main">
+  <p:cSld>
+    <p:spTree>
+      <p:nvGrpSpPr>
+        <p:cNvPr id="1" name=""/>
+        <p:cNvGrpSpPr/>
+        <p:nvPr/>
+      </p:nvGrpSpPr>
+      <p:grpSpPr>
+        <a:xfrm>
+          <a:off x="0" y="0"/>
+          <a:ext cx="0" cy="0"/>
+          <a:chOff x="0" y="0"/>
+          <a:chExt cx="0" cy="0"/>
+        </a:xfrm>
+      </p:grpSpPr>
+      <p:pic>
+        <p:nvPicPr>
+          <p:cNvPr id="2" name="Slide 30"/>
+          <p:cNvPicPr>
+            <a:picLocks noChangeAspect="1"/>
+          </p:cNvPicPr>
+          <p:nvPr/>
+        </p:nvPicPr>
+        <p:blipFill>
+          <a:blip r:embed="rId2"/>
+          <a:stretch>
+            <a:fillRect/>
+          </a:stretch>
+        </p:blipFill>
+        <p:spPr>
+          <a:xfrm>
+            <a:off x="0" y="0"/>
+            <a:ext cx="12192000" cy="6858000"/>
+          </a:xfrm>
+          <a:prstGeom prst="rect">
+            <a:avLst/>
+          </a:prstGeom>
+        </p:spPr>
+      </p:pic>
+    </p:spTree>
+  </p:cSld>
+  <p:clrMapOvr>
+    <a:masterClrMapping/>
+  </p:clrMapOvr>
+</p:sld>
+</file>
+
+<file path=ppt/slides/slide31.xml><?xml version="1.0" encoding="utf-8"?>
+<p:sld xmlns:a="http://schemas.openxmlformats.org/drawingml/2006/main" xmlns:r="http://schemas.openxmlformats.org/officeDocument/2006/relationships" xmlns:p="http://schemas.openxmlformats.org/presentationml/2006/main">
+  <p:cSld>
+    <p:spTree>
+      <p:nvGrpSpPr>
+        <p:cNvPr id="1" name=""/>
+        <p:cNvGrpSpPr/>
+        <p:nvPr/>
+      </p:nvGrpSpPr>
+      <p:grpSpPr>
+        <a:xfrm>
+          <a:off x="0" y="0"/>
+          <a:ext cx="0" cy="0"/>
+          <a:chOff x="0" y="0"/>
+          <a:chExt cx="0" cy="0"/>
+        </a:xfrm>
+      </p:grpSpPr>
+      <p:pic>
+        <p:nvPicPr>
+          <p:cNvPr id="2" name="Slide 31"/>
+          <p:cNvPicPr>
+            <a:picLocks noChangeAspect="1"/>
+          </p:cNvPicPr>
+          <p:nvPr/>
+        </p:nvPicPr>
+        <p:blipFill>
+          <a:blip r:embed="rId2"/>
+          <a:stretch>
+            <a:fillRect/>
+          </a:stretch>
+        </p:blipFill>
+        <p:spPr>
+          <a:xfrm>
+            <a:off x="0" y="0"/>
+            <a:ext cx="12192000" cy="6858000"/>
+          </a:xfrm>
+          <a:prstGeom prst="rect">
+            <a:avLst/>
+          </a:prstGeom>
+        </p:spPr>
+      </p:pic>
+    </p:spTree>
+  </p:cSld>
+  <p:clrMapOvr>
+    <a:masterClrMapping/>
+  </p:clrMapOvr>
+</p:sld>
+</file>
+
+<file path=ppt/slides/slide32.xml><?xml version="1.0" encoding="utf-8"?>
+<p:sld xmlns:a="http://schemas.openxmlformats.org/drawingml/2006/main" xmlns:r="http://schemas.openxmlformats.org/officeDocument/2006/relationships" xmlns:p="http://schemas.openxmlformats.org/presentationml/2006/main">
+  <p:cSld>
+    <p:spTree>
+      <p:nvGrpSpPr>
+        <p:cNvPr id="1" name=""/>
+        <p:cNvGrpSpPr/>
+        <p:nvPr/>
+      </p:nvGrpSpPr>
+      <p:grpSpPr>
+        <a:xfrm>
+          <a:off x="0" y="0"/>
+          <a:ext cx="0" cy="0"/>
+          <a:chOff x="0" y="0"/>
+          <a:chExt cx="0" cy="0"/>
+        </a:xfrm>
+      </p:grpSpPr>
+      <p:pic>
+        <p:nvPicPr>
+          <p:cNvPr id="2" name="Slide 32"/>
+          <p:cNvPicPr>
+            <a:picLocks noChangeAspect="1"/>
+          </p:cNvPicPr>
+          <p:nvPr/>
+        </p:nvPicPr>
+        <p:blipFill>
+          <a:blip r:embed="rId2"/>
+          <a:stretch>
+            <a:fillRect/>
+          </a:stretch>
+        </p:blipFill>
+        <p:spPr>
+          <a:xfrm>
+            <a:off x="0" y="0"/>
+            <a:ext cx="12192000" cy="6858000"/>
+          </a:xfrm>
+          <a:prstGeom prst="rect">
+            <a:avLst/>
+          </a:prstGeom>
+        </p:spPr>
+      </p:pic>
+    </p:spTree>
+  </p:cSld>
+  <p:clrMapOvr>
+    <a:masterClrMapping/>
+  </p:clrMapOvr>
+</p:sld>
+</file>
+
+<file path=ppt/slides/slide33.xml><?xml version="1.0" encoding="utf-8"?>
+<p:sld xmlns:a="http://schemas.openxmlformats.org/drawingml/2006/main" xmlns:r="http://schemas.openxmlformats.org/officeDocument/2006/relationships" xmlns:p="http://schemas.openxmlformats.org/presentationml/2006/main">
+  <p:cSld>
+    <p:spTree>
+      <p:nvGrpSpPr>
+        <p:cNvPr id="1" name=""/>
+        <p:cNvGrpSpPr/>
+        <p:nvPr/>
+      </p:nvGrpSpPr>
+      <p:grpSpPr>
+        <a:xfrm>
+          <a:off x="0" y="0"/>
+          <a:ext cx="0" cy="0"/>
+          <a:chOff x="0" y="0"/>
+          <a:chExt cx="0" cy="0"/>
+        </a:xfrm>
+      </p:grpSpPr>
+      <p:pic>
+        <p:nvPicPr>
+          <p:cNvPr id="2" name="Slide 33"/>
           <p:cNvPicPr>
             <a:picLocks noChangeAspect="1"/>
           </p:cNvPicPr>

</xml_diff>